<commit_message>
Rich agent answers, thinking bubble, library-access intent, variable-length docs, demote duplicate copies
- Agent: library-access handler reads real library permissions; Markdown-rich answers rendered safely in the UI; animated thinking bubble
- Foundry agent instructions: use live evidence for governance questions, rich Markdown format
- Corpus: random (stable) page/slide/sheet counts; copies seeded as Draft duplicates of approved originals
- Fix agent provisioning: keep governance source fields, multi-hub smoke test
- Refresh screenshots, agent test and READMEs

Co-authored-by: Copilot <223556219+Copilot@users.noreply.github.com>
</commit_message>
<xml_diff>
--- a/data/sites/hr/HR Policies/global-workplace-governance-architecture-deck (copy).pptx
+++ b/data/sites/hr/HR Policies/global-workplace-governance-architecture-deck (copy).pptx
@@ -17,6 +17,8 @@
     <p:sldId id="265" r:id="rId16"/>
     <p:sldId id="266" r:id="rId17"/>
     <p:sldId id="267" r:id="rId18"/>
+    <p:sldId id="268" r:id="rId19"/>
+    <p:sldId id="269" r:id="rId20"/>
   </p:sldIdLst>
   <p:sldSz cx="12191695" cy="6858000" type="screen4x3"/>
   <p:notesSz cx="6858000" cy="9144000"/>
@@ -4373,7 +4375,7 @@
           <a:lstStyle/>
           <a:p>
             <a:r>
-              <a:t>12. Appendix, Lineage &amp; Sign-off - Global Workplace Governance Architec</a:t>
+              <a:t>12. Training &amp; Change Management - Global Workplace Governance Architec</a:t>
             </a:r>
           </a:p>
         </p:txBody>
@@ -4394,7 +4396,7 @@
           <a:lstStyle/>
           <a:p>
             <a:r>
-              <a:t>Twelve-slide executive presentation covering global HR policy architecture, regional compliance matrices, escalation paths, and annual audit readiness. Section 12 (Appendix, Lineage &amp; Sign-off) applies to HR Policies within HR Knowledge Hub and is maintained by Maria Chen. Records document lineage, governance metadata, version history, and owner sign-off.</a:t>
+              <a:t>Twelve-slide executive presentation covering global HR policy architecture, regional compliance matrices, escalation paths, and annual audit readiness. Section 12 (Training &amp; Change Management) applies to HR Policies within HR Knowledge Hub and is maintained by Maria Chen. Plans enablement sessions, communications, and adoption checkpoints for affected teams.</a:t>
             </a:r>
           </a:p>
           <a:p>
@@ -4745,6 +4747,886 @@
                       </a:pPr>
                       <a:r>
                         <a:t>Stage 12 Verified</a:t>
+                      </a:r>
+                    </a:p>
+                  </a:txBody>
+                  <a:tcPr/>
+                </a:tc>
+              </a:tr>
+            </a:tbl>
+          </a:graphicData>
+        </a:graphic>
+      </p:graphicFrame>
+      <p:pic>
+        <p:nvPicPr>
+          <p:cNvPr id="5" name="Picture 4" descr="image.png"/>
+          <p:cNvPicPr>
+            <a:picLocks noChangeAspect="1"/>
+          </p:cNvPicPr>
+          <p:nvPr/>
+        </p:nvPicPr>
+        <p:blipFill>
+          <a:blip r:embed="rId2"/>
+          <a:stretch>
+            <a:fillRect/>
+          </a:stretch>
+        </p:blipFill>
+        <p:spPr>
+          <a:xfrm>
+            <a:off x="6492240" y="3703320"/>
+            <a:ext cx="5120640" cy="1828800"/>
+          </a:xfrm>
+          <a:prstGeom prst="rect">
+            <a:avLst/>
+          </a:prstGeom>
+        </p:spPr>
+      </p:pic>
+    </p:spTree>
+  </p:cSld>
+  <p:clrMapOvr>
+    <a:masterClrMapping/>
+  </p:clrMapOvr>
+</p:sld>
+</file>
+
+<file path=ppt/slides/slide13.xml><?xml version="1.0" encoding="utf-8"?>
+<p:sld xmlns:a="http://schemas.openxmlformats.org/drawingml/2006/main" xmlns:p="http://schemas.openxmlformats.org/presentationml/2006/main" xmlns:r="http://schemas.openxmlformats.org/officeDocument/2006/relationships">
+  <p:cSld>
+    <p:spTree>
+      <p:nvGrpSpPr>
+        <p:cNvPr id="1" name=""/>
+        <p:cNvGrpSpPr/>
+        <p:nvPr/>
+      </p:nvGrpSpPr>
+      <p:grpSpPr/>
+      <p:sp>
+        <p:nvSpPr>
+          <p:cNvPr id="2" name="Title 1"/>
+          <p:cNvSpPr>
+            <a:spLocks noGrp="1"/>
+          </p:cNvSpPr>
+          <p:nvPr>
+            <p:ph type="title"/>
+          </p:nvPr>
+        </p:nvSpPr>
+        <p:spPr/>
+        <p:txBody>
+          <a:bodyPr/>
+          <a:lstStyle/>
+          <a:p>
+            <a:r>
+              <a:t>13. Technology &amp; Tooling Landscape - Global Workplace Governance Architec</a:t>
+            </a:r>
+          </a:p>
+        </p:txBody>
+      </p:sp>
+      <p:sp>
+        <p:nvSpPr>
+          <p:cNvPr id="3" name="Content Placeholder 2"/>
+          <p:cNvSpPr>
+            <a:spLocks noGrp="1"/>
+          </p:cNvSpPr>
+          <p:nvPr>
+            <p:ph idx="1"/>
+          </p:nvPr>
+        </p:nvSpPr>
+        <p:spPr/>
+        <p:txBody>
+          <a:bodyPr/>
+          <a:lstStyle/>
+          <a:p>
+            <a:r>
+              <a:t>Twelve-slide executive presentation covering global HR policy architecture, regional compliance matrices, escalation paths, and annual audit readiness. Section 13 (Technology &amp; Tooling Landscape) applies to HR Policies within HR Knowledge Hub and is maintained by Maria Chen. Lists supporting systems, integrations, configuration owners, and upgrade cadence.</a:t>
+            </a:r>
+          </a:p>
+          <a:p>
+            <a:pPr lvl="1"/>
+            <a:r>
+              <a:t>Standardizes policy governance across North America, EMEA, and APAC hubs.</a:t>
+            </a:r>
+          </a:p>
+          <a:p>
+            <a:pPr lvl="1"/>
+            <a:r>
+              <a:t>Maps statutory compliance controls to quarterly HR Business Partner audit checkpoints.</a:t>
+            </a:r>
+          </a:p>
+          <a:p>
+            <a:pPr lvl="1"/>
+            <a:r>
+              <a:t>Section 13 review cadence is tracked by Maria Chen under HR Policies governance.</a:t>
+            </a:r>
+          </a:p>
+        </p:txBody>
+      </p:sp>
+      <p:graphicFrame>
+        <p:nvGraphicFramePr>
+          <p:cNvPr id="4" name="Table 3"/>
+          <p:cNvGraphicFramePr>
+            <a:graphicFrameLocks noGrp="1"/>
+          </p:cNvGraphicFramePr>
+          <p:nvPr/>
+        </p:nvGraphicFramePr>
+        <p:xfrm>
+          <a:off x="548640" y="3749039"/>
+          <a:ext cx="5669280" cy="1737360"/>
+        </p:xfrm>
+        <a:graphic>
+          <a:graphicData uri="http://schemas.openxmlformats.org/drawingml/2006/table">
+            <a:tbl>
+              <a:tblPr firstRow="1" bandRow="1">
+                <a:tableStyleId>{5C22544A-7EE6-4342-B048-85BDC9FD1C3A}</a:tableStyleId>
+              </a:tblPr>
+              <a:tblGrid>
+                <a:gridCol w="1417320"/>
+                <a:gridCol w="1417320"/>
+                <a:gridCol w="1417320"/>
+                <a:gridCol w="1417320"/>
+              </a:tblGrid>
+              <a:tr h="347472">
+                <a:tc>
+                  <a:txBody>
+                    <a:bodyPr/>
+                    <a:lstStyle/>
+                    <a:p>
+                      <a:pPr>
+                        <a:defRPr b="1" sz="1100"/>
+                      </a:pPr>
+                      <a:r>
+                        <a:t>Region</a:t>
+                      </a:r>
+                    </a:p>
+                  </a:txBody>
+                  <a:tcPr/>
+                </a:tc>
+                <a:tc>
+                  <a:txBody>
+                    <a:bodyPr/>
+                    <a:lstStyle/>
+                    <a:p>
+                      <a:pPr>
+                        <a:defRPr b="1" sz="1100"/>
+                      </a:pPr>
+                      <a:r>
+                        <a:t>Policy Coverage</a:t>
+                      </a:r>
+                    </a:p>
+                  </a:txBody>
+                  <a:tcPr/>
+                </a:tc>
+                <a:tc>
+                  <a:txBody>
+                    <a:bodyPr/>
+                    <a:lstStyle/>
+                    <a:p>
+                      <a:pPr>
+                        <a:defRPr b="1" sz="1100"/>
+                      </a:pPr>
+                      <a:r>
+                        <a:t>Audit SLA</a:t>
+                      </a:r>
+                    </a:p>
+                  </a:txBody>
+                  <a:tcPr/>
+                </a:tc>
+                <a:tc>
+                  <a:txBody>
+                    <a:bodyPr/>
+                    <a:lstStyle/>
+                    <a:p>
+                      <a:pPr>
+                        <a:defRPr b="1" sz="1100"/>
+                      </a:pPr>
+                      <a:r>
+                        <a:t>Compliance Score</a:t>
+                      </a:r>
+                    </a:p>
+                  </a:txBody>
+                  <a:tcPr/>
+                </a:tc>
+              </a:tr>
+              <a:tr h="347472">
+                <a:tc>
+                  <a:txBody>
+                    <a:bodyPr/>
+                    <a:lstStyle/>
+                    <a:p>
+                      <a:pPr>
+                        <a:defRPr sz="1000"/>
+                      </a:pPr>
+                      <a:r>
+                        <a:t>North America</a:t>
+                      </a:r>
+                    </a:p>
+                  </a:txBody>
+                  <a:tcPr/>
+                </a:tc>
+                <a:tc>
+                  <a:txBody>
+                    <a:bodyPr/>
+                    <a:lstStyle/>
+                    <a:p>
+                      <a:pPr>
+                        <a:defRPr sz="1000"/>
+                      </a:pPr>
+                      <a:r>
+                        <a:t>100%</a:t>
+                      </a:r>
+                    </a:p>
+                  </a:txBody>
+                  <a:tcPr/>
+                </a:tc>
+                <a:tc>
+                  <a:txBody>
+                    <a:bodyPr/>
+                    <a:lstStyle/>
+                    <a:p>
+                      <a:pPr>
+                        <a:defRPr sz="1000"/>
+                      </a:pPr>
+                      <a:r>
+                        <a:t>5 business days</a:t>
+                      </a:r>
+                    </a:p>
+                  </a:txBody>
+                  <a:tcPr/>
+                </a:tc>
+                <a:tc>
+                  <a:txBody>
+                    <a:bodyPr/>
+                    <a:lstStyle/>
+                    <a:p>
+                      <a:pPr>
+                        <a:defRPr sz="1000"/>
+                      </a:pPr>
+                      <a:r>
+                        <a:t>98.4%</a:t>
+                      </a:r>
+                    </a:p>
+                  </a:txBody>
+                  <a:tcPr/>
+                </a:tc>
+              </a:tr>
+              <a:tr h="347472">
+                <a:tc>
+                  <a:txBody>
+                    <a:bodyPr/>
+                    <a:lstStyle/>
+                    <a:p>
+                      <a:pPr>
+                        <a:defRPr sz="1000"/>
+                      </a:pPr>
+                      <a:r>
+                        <a:t>EMEA</a:t>
+                      </a:r>
+                    </a:p>
+                  </a:txBody>
+                  <a:tcPr/>
+                </a:tc>
+                <a:tc>
+                  <a:txBody>
+                    <a:bodyPr/>
+                    <a:lstStyle/>
+                    <a:p>
+                      <a:pPr>
+                        <a:defRPr sz="1000"/>
+                      </a:pPr>
+                      <a:r>
+                        <a:t>99%</a:t>
+                      </a:r>
+                    </a:p>
+                  </a:txBody>
+                  <a:tcPr/>
+                </a:tc>
+                <a:tc>
+                  <a:txBody>
+                    <a:bodyPr/>
+                    <a:lstStyle/>
+                    <a:p>
+                      <a:pPr>
+                        <a:defRPr sz="1000"/>
+                      </a:pPr>
+                      <a:r>
+                        <a:t>5 business days</a:t>
+                      </a:r>
+                    </a:p>
+                  </a:txBody>
+                  <a:tcPr/>
+                </a:tc>
+                <a:tc>
+                  <a:txBody>
+                    <a:bodyPr/>
+                    <a:lstStyle/>
+                    <a:p>
+                      <a:pPr>
+                        <a:defRPr sz="1000"/>
+                      </a:pPr>
+                      <a:r>
+                        <a:t>97.9%</a:t>
+                      </a:r>
+                    </a:p>
+                  </a:txBody>
+                  <a:tcPr/>
+                </a:tc>
+              </a:tr>
+              <a:tr h="347472">
+                <a:tc>
+                  <a:txBody>
+                    <a:bodyPr/>
+                    <a:lstStyle/>
+                    <a:p>
+                      <a:pPr>
+                        <a:defRPr sz="1000"/>
+                      </a:pPr>
+                      <a:r>
+                        <a:t>APAC</a:t>
+                      </a:r>
+                    </a:p>
+                  </a:txBody>
+                  <a:tcPr/>
+                </a:tc>
+                <a:tc>
+                  <a:txBody>
+                    <a:bodyPr/>
+                    <a:lstStyle/>
+                    <a:p>
+                      <a:pPr>
+                        <a:defRPr sz="1000"/>
+                      </a:pPr>
+                      <a:r>
+                        <a:t>98%</a:t>
+                      </a:r>
+                    </a:p>
+                  </a:txBody>
+                  <a:tcPr/>
+                </a:tc>
+                <a:tc>
+                  <a:txBody>
+                    <a:bodyPr/>
+                    <a:lstStyle/>
+                    <a:p>
+                      <a:pPr>
+                        <a:defRPr sz="1000"/>
+                      </a:pPr>
+                      <a:r>
+                        <a:t>7 business days</a:t>
+                      </a:r>
+                    </a:p>
+                  </a:txBody>
+                  <a:tcPr/>
+                </a:tc>
+                <a:tc>
+                  <a:txBody>
+                    <a:bodyPr/>
+                    <a:lstStyle/>
+                    <a:p>
+                      <a:pPr>
+                        <a:defRPr sz="1000"/>
+                      </a:pPr>
+                      <a:r>
+                        <a:t>96.8%</a:t>
+                      </a:r>
+                    </a:p>
+                  </a:txBody>
+                  <a:tcPr/>
+                </a:tc>
+              </a:tr>
+              <a:tr h="347472">
+                <a:tc>
+                  <a:txBody>
+                    <a:bodyPr/>
+                    <a:lstStyle/>
+                    <a:p>
+                      <a:pPr>
+                        <a:defRPr sz="1000"/>
+                      </a:pPr>
+                      <a:r>
+                        <a:t>Sec-13</a:t>
+                      </a:r>
+                    </a:p>
+                  </a:txBody>
+                  <a:tcPr/>
+                </a:tc>
+                <a:tc>
+                  <a:txBody>
+                    <a:bodyPr/>
+                    <a:lstStyle/>
+                    <a:p>
+                      <a:pPr>
+                        <a:defRPr sz="1000"/>
+                      </a:pPr>
+                      <a:r>
+                        <a:t>100%</a:t>
+                      </a:r>
+                    </a:p>
+                  </a:txBody>
+                  <a:tcPr/>
+                </a:tc>
+                <a:tc>
+                  <a:txBody>
+                    <a:bodyPr/>
+                    <a:lstStyle/>
+                    <a:p>
+                      <a:pPr>
+                        <a:defRPr sz="1000"/>
+                      </a:pPr>
+                      <a:r>
+                        <a:t>5 business days</a:t>
+                      </a:r>
+                    </a:p>
+                  </a:txBody>
+                  <a:tcPr/>
+                </a:tc>
+                <a:tc>
+                  <a:txBody>
+                    <a:bodyPr/>
+                    <a:lstStyle/>
+                    <a:p>
+                      <a:pPr>
+                        <a:defRPr sz="1000"/>
+                      </a:pPr>
+                      <a:r>
+                        <a:t>Stage 13 Verified</a:t>
+                      </a:r>
+                    </a:p>
+                  </a:txBody>
+                  <a:tcPr/>
+                </a:tc>
+              </a:tr>
+            </a:tbl>
+          </a:graphicData>
+        </a:graphic>
+      </p:graphicFrame>
+      <p:pic>
+        <p:nvPicPr>
+          <p:cNvPr id="5" name="Picture 4" descr="image.png"/>
+          <p:cNvPicPr>
+            <a:picLocks noChangeAspect="1"/>
+          </p:cNvPicPr>
+          <p:nvPr/>
+        </p:nvPicPr>
+        <p:blipFill>
+          <a:blip r:embed="rId2"/>
+          <a:stretch>
+            <a:fillRect/>
+          </a:stretch>
+        </p:blipFill>
+        <p:spPr>
+          <a:xfrm>
+            <a:off x="6492240" y="3703320"/>
+            <a:ext cx="5120640" cy="1828800"/>
+          </a:xfrm>
+          <a:prstGeom prst="rect">
+            <a:avLst/>
+          </a:prstGeom>
+        </p:spPr>
+      </p:pic>
+    </p:spTree>
+  </p:cSld>
+  <p:clrMapOvr>
+    <a:masterClrMapping/>
+  </p:clrMapOvr>
+</p:sld>
+</file>
+
+<file path=ppt/slides/slide14.xml><?xml version="1.0" encoding="utf-8"?>
+<p:sld xmlns:a="http://schemas.openxmlformats.org/drawingml/2006/main" xmlns:p="http://schemas.openxmlformats.org/presentationml/2006/main" xmlns:r="http://schemas.openxmlformats.org/officeDocument/2006/relationships">
+  <p:cSld>
+    <p:spTree>
+      <p:nvGrpSpPr>
+        <p:cNvPr id="1" name=""/>
+        <p:cNvGrpSpPr/>
+        <p:nvPr/>
+      </p:nvGrpSpPr>
+      <p:grpSpPr/>
+      <p:sp>
+        <p:nvSpPr>
+          <p:cNvPr id="2" name="Title 1"/>
+          <p:cNvSpPr>
+            <a:spLocks noGrp="1"/>
+          </p:cNvSpPr>
+          <p:nvPr>
+            <p:ph type="title"/>
+          </p:nvPr>
+        </p:nvSpPr>
+        <p:spPr/>
+        <p:txBody>
+          <a:bodyPr/>
+          <a:lstStyle/>
+          <a:p>
+            <a:r>
+              <a:t>14. Appendix, Lineage &amp; Sign-off - Global Workplace Governance Architec</a:t>
+            </a:r>
+          </a:p>
+        </p:txBody>
+      </p:sp>
+      <p:sp>
+        <p:nvSpPr>
+          <p:cNvPr id="3" name="Content Placeholder 2"/>
+          <p:cNvSpPr>
+            <a:spLocks noGrp="1"/>
+          </p:cNvSpPr>
+          <p:nvPr>
+            <p:ph idx="1"/>
+          </p:nvPr>
+        </p:nvSpPr>
+        <p:spPr/>
+        <p:txBody>
+          <a:bodyPr/>
+          <a:lstStyle/>
+          <a:p>
+            <a:r>
+              <a:t>Twelve-slide executive presentation covering global HR policy architecture, regional compliance matrices, escalation paths, and annual audit readiness. Section 14 (Appendix, Lineage &amp; Sign-off) applies to HR Policies within HR Knowledge Hub and is maintained by Maria Chen. Records document lineage, governance metadata, version history, and owner sign-off.</a:t>
+            </a:r>
+          </a:p>
+          <a:p>
+            <a:pPr lvl="1"/>
+            <a:r>
+              <a:t>Maps statutory compliance controls to quarterly HR Business Partner audit checkpoints.</a:t>
+            </a:r>
+          </a:p>
+          <a:p>
+            <a:pPr lvl="1"/>
+            <a:r>
+              <a:t>Integrates incident intake, investigation SLAs, and executive reporting dashboards.</a:t>
+            </a:r>
+          </a:p>
+          <a:p>
+            <a:pPr lvl="1"/>
+            <a:r>
+              <a:t>Section 14 review cadence is tracked by Maria Chen under HR Policies governance.</a:t>
+            </a:r>
+          </a:p>
+        </p:txBody>
+      </p:sp>
+      <p:graphicFrame>
+        <p:nvGraphicFramePr>
+          <p:cNvPr id="4" name="Table 3"/>
+          <p:cNvGraphicFramePr>
+            <a:graphicFrameLocks noGrp="1"/>
+          </p:cNvGraphicFramePr>
+          <p:nvPr/>
+        </p:nvGraphicFramePr>
+        <p:xfrm>
+          <a:off x="548640" y="3749039"/>
+          <a:ext cx="5669280" cy="1737360"/>
+        </p:xfrm>
+        <a:graphic>
+          <a:graphicData uri="http://schemas.openxmlformats.org/drawingml/2006/table">
+            <a:tbl>
+              <a:tblPr firstRow="1" bandRow="1">
+                <a:tableStyleId>{5C22544A-7EE6-4342-B048-85BDC9FD1C3A}</a:tableStyleId>
+              </a:tblPr>
+              <a:tblGrid>
+                <a:gridCol w="1417320"/>
+                <a:gridCol w="1417320"/>
+                <a:gridCol w="1417320"/>
+                <a:gridCol w="1417320"/>
+              </a:tblGrid>
+              <a:tr h="347472">
+                <a:tc>
+                  <a:txBody>
+                    <a:bodyPr/>
+                    <a:lstStyle/>
+                    <a:p>
+                      <a:pPr>
+                        <a:defRPr b="1" sz="1100"/>
+                      </a:pPr>
+                      <a:r>
+                        <a:t>Region</a:t>
+                      </a:r>
+                    </a:p>
+                  </a:txBody>
+                  <a:tcPr/>
+                </a:tc>
+                <a:tc>
+                  <a:txBody>
+                    <a:bodyPr/>
+                    <a:lstStyle/>
+                    <a:p>
+                      <a:pPr>
+                        <a:defRPr b="1" sz="1100"/>
+                      </a:pPr>
+                      <a:r>
+                        <a:t>Policy Coverage</a:t>
+                      </a:r>
+                    </a:p>
+                  </a:txBody>
+                  <a:tcPr/>
+                </a:tc>
+                <a:tc>
+                  <a:txBody>
+                    <a:bodyPr/>
+                    <a:lstStyle/>
+                    <a:p>
+                      <a:pPr>
+                        <a:defRPr b="1" sz="1100"/>
+                      </a:pPr>
+                      <a:r>
+                        <a:t>Audit SLA</a:t>
+                      </a:r>
+                    </a:p>
+                  </a:txBody>
+                  <a:tcPr/>
+                </a:tc>
+                <a:tc>
+                  <a:txBody>
+                    <a:bodyPr/>
+                    <a:lstStyle/>
+                    <a:p>
+                      <a:pPr>
+                        <a:defRPr b="1" sz="1100"/>
+                      </a:pPr>
+                      <a:r>
+                        <a:t>Compliance Score</a:t>
+                      </a:r>
+                    </a:p>
+                  </a:txBody>
+                  <a:tcPr/>
+                </a:tc>
+              </a:tr>
+              <a:tr h="347472">
+                <a:tc>
+                  <a:txBody>
+                    <a:bodyPr/>
+                    <a:lstStyle/>
+                    <a:p>
+                      <a:pPr>
+                        <a:defRPr sz="1000"/>
+                      </a:pPr>
+                      <a:r>
+                        <a:t>North America</a:t>
+                      </a:r>
+                    </a:p>
+                  </a:txBody>
+                  <a:tcPr/>
+                </a:tc>
+                <a:tc>
+                  <a:txBody>
+                    <a:bodyPr/>
+                    <a:lstStyle/>
+                    <a:p>
+                      <a:pPr>
+                        <a:defRPr sz="1000"/>
+                      </a:pPr>
+                      <a:r>
+                        <a:t>100%</a:t>
+                      </a:r>
+                    </a:p>
+                  </a:txBody>
+                  <a:tcPr/>
+                </a:tc>
+                <a:tc>
+                  <a:txBody>
+                    <a:bodyPr/>
+                    <a:lstStyle/>
+                    <a:p>
+                      <a:pPr>
+                        <a:defRPr sz="1000"/>
+                      </a:pPr>
+                      <a:r>
+                        <a:t>5 business days</a:t>
+                      </a:r>
+                    </a:p>
+                  </a:txBody>
+                  <a:tcPr/>
+                </a:tc>
+                <a:tc>
+                  <a:txBody>
+                    <a:bodyPr/>
+                    <a:lstStyle/>
+                    <a:p>
+                      <a:pPr>
+                        <a:defRPr sz="1000"/>
+                      </a:pPr>
+                      <a:r>
+                        <a:t>98.4%</a:t>
+                      </a:r>
+                    </a:p>
+                  </a:txBody>
+                  <a:tcPr/>
+                </a:tc>
+              </a:tr>
+              <a:tr h="347472">
+                <a:tc>
+                  <a:txBody>
+                    <a:bodyPr/>
+                    <a:lstStyle/>
+                    <a:p>
+                      <a:pPr>
+                        <a:defRPr sz="1000"/>
+                      </a:pPr>
+                      <a:r>
+                        <a:t>EMEA</a:t>
+                      </a:r>
+                    </a:p>
+                  </a:txBody>
+                  <a:tcPr/>
+                </a:tc>
+                <a:tc>
+                  <a:txBody>
+                    <a:bodyPr/>
+                    <a:lstStyle/>
+                    <a:p>
+                      <a:pPr>
+                        <a:defRPr sz="1000"/>
+                      </a:pPr>
+                      <a:r>
+                        <a:t>99%</a:t>
+                      </a:r>
+                    </a:p>
+                  </a:txBody>
+                  <a:tcPr/>
+                </a:tc>
+                <a:tc>
+                  <a:txBody>
+                    <a:bodyPr/>
+                    <a:lstStyle/>
+                    <a:p>
+                      <a:pPr>
+                        <a:defRPr sz="1000"/>
+                      </a:pPr>
+                      <a:r>
+                        <a:t>5 business days</a:t>
+                      </a:r>
+                    </a:p>
+                  </a:txBody>
+                  <a:tcPr/>
+                </a:tc>
+                <a:tc>
+                  <a:txBody>
+                    <a:bodyPr/>
+                    <a:lstStyle/>
+                    <a:p>
+                      <a:pPr>
+                        <a:defRPr sz="1000"/>
+                      </a:pPr>
+                      <a:r>
+                        <a:t>97.9%</a:t>
+                      </a:r>
+                    </a:p>
+                  </a:txBody>
+                  <a:tcPr/>
+                </a:tc>
+              </a:tr>
+              <a:tr h="347472">
+                <a:tc>
+                  <a:txBody>
+                    <a:bodyPr/>
+                    <a:lstStyle/>
+                    <a:p>
+                      <a:pPr>
+                        <a:defRPr sz="1000"/>
+                      </a:pPr>
+                      <a:r>
+                        <a:t>APAC</a:t>
+                      </a:r>
+                    </a:p>
+                  </a:txBody>
+                  <a:tcPr/>
+                </a:tc>
+                <a:tc>
+                  <a:txBody>
+                    <a:bodyPr/>
+                    <a:lstStyle/>
+                    <a:p>
+                      <a:pPr>
+                        <a:defRPr sz="1000"/>
+                      </a:pPr>
+                      <a:r>
+                        <a:t>98%</a:t>
+                      </a:r>
+                    </a:p>
+                  </a:txBody>
+                  <a:tcPr/>
+                </a:tc>
+                <a:tc>
+                  <a:txBody>
+                    <a:bodyPr/>
+                    <a:lstStyle/>
+                    <a:p>
+                      <a:pPr>
+                        <a:defRPr sz="1000"/>
+                      </a:pPr>
+                      <a:r>
+                        <a:t>7 business days</a:t>
+                      </a:r>
+                    </a:p>
+                  </a:txBody>
+                  <a:tcPr/>
+                </a:tc>
+                <a:tc>
+                  <a:txBody>
+                    <a:bodyPr/>
+                    <a:lstStyle/>
+                    <a:p>
+                      <a:pPr>
+                        <a:defRPr sz="1000"/>
+                      </a:pPr>
+                      <a:r>
+                        <a:t>96.8%</a:t>
+                      </a:r>
+                    </a:p>
+                  </a:txBody>
+                  <a:tcPr/>
+                </a:tc>
+              </a:tr>
+              <a:tr h="347472">
+                <a:tc>
+                  <a:txBody>
+                    <a:bodyPr/>
+                    <a:lstStyle/>
+                    <a:p>
+                      <a:pPr>
+                        <a:defRPr sz="1000"/>
+                      </a:pPr>
+                      <a:r>
+                        <a:t>Sec-14</a:t>
+                      </a:r>
+                    </a:p>
+                  </a:txBody>
+                  <a:tcPr/>
+                </a:tc>
+                <a:tc>
+                  <a:txBody>
+                    <a:bodyPr/>
+                    <a:lstStyle/>
+                    <a:p>
+                      <a:pPr>
+                        <a:defRPr sz="1000"/>
+                      </a:pPr>
+                      <a:r>
+                        <a:t>99%</a:t>
+                      </a:r>
+                    </a:p>
+                  </a:txBody>
+                  <a:tcPr/>
+                </a:tc>
+                <a:tc>
+                  <a:txBody>
+                    <a:bodyPr/>
+                    <a:lstStyle/>
+                    <a:p>
+                      <a:pPr>
+                        <a:defRPr sz="1000"/>
+                      </a:pPr>
+                      <a:r>
+                        <a:t>5 business days</a:t>
+                      </a:r>
+                    </a:p>
+                  </a:txBody>
+                  <a:tcPr/>
+                </a:tc>
+                <a:tc>
+                  <a:txBody>
+                    <a:bodyPr/>
+                    <a:lstStyle/>
+                    <a:p>
+                      <a:pPr>
+                        <a:defRPr sz="1000"/>
+                      </a:pPr>
+                      <a:r>
+                        <a:t>Stage 14 Verified</a:t>
                       </a:r>
                     </a:p>
                   </a:txBody>

</xml_diff>